<commit_message>
docs(pitch): deck en HTML/PDF con Chrome headless y métrica de capacidad
- scripts/make_deck_pdf.py: deck.md -> deck.html + deck.pdf (+ capturas por slide
  para QA visual sin Office); notas del orador en un anexo
- metrics.yaml: capacidad desde reports/capacity.md

Co-Authored-By: Claude Opus 5.5 <noreply@anthropic.com>
</commit_message>
<xml_diff>
--- a/docs/pitch/deck.pptx
+++ b/docs/pitch/deck.pptx
@@ -7665,7 +7665,7 @@
                 </a:solidFill>
                 <a:latin typeface="Calibri"/>
               </a:rPr>
-              <a:t>25 tests automatizados en CI (sin datos ni API keys): flujos normal/ambiguo/handoff, sesión vencida, acceso ajeno, inyección directa e indirecta, cliente señuelo</a:t>
+              <a:t>80 tests automatizados en CI (sin datos ni API keys): flujos normal/ambiguo/handoff, sesión vencida, acceso ajeno, inyección directa e indirecta, cliente señuelo</a:t>
             </a:r>
           </a:p>
         </p:txBody>
@@ -9008,11 +9008,11 @@
             <a:r>
               <a:rPr sz="1600" b="0" i="0">
                 <a:solidFill>
-                  <a:srgbClr val="B54A1A"/>
-                </a:solidFill>
-                <a:latin typeface="Calibri"/>
-              </a:rPr>
-              <a:t>Capacidad: [[PENDIENTE: reports/capacity.md]]</a:t>
+                  <a:srgbClr val="0B0B0B"/>
+                </a:solidFill>
+                <a:latin typeface="Calibri"/>
+              </a:rPr>
+              <a:t>Capacidad: p95 233 ms por turno · ~61 turnos/s por réplica (sin LLM, costo $0)</a:t>
             </a:r>
           </a:p>
         </p:txBody>

</xml_diff>

<commit_message>
docs(pitch): deck en HTML/PDF con Chrome headless y métrica de capacidad (#46)
- scripts/make_deck_pdf.py: deck.md -> deck.html + deck.pdf (+ capturas por slide
  para QA visual sin Office); notas del orador en un anexo
- metrics.yaml: capacidad desde reports/capacity.md

Co-authored-by: Mr-Percival <188080720.Mr-Percival@users.noreply.github.com>
Co-authored-by: Claude Opus 5.5 <noreply@anthropic.com>
</commit_message>
<xml_diff>
--- a/docs/pitch/deck.pptx
+++ b/docs/pitch/deck.pptx
@@ -7665,7 +7665,7 @@
                 </a:solidFill>
                 <a:latin typeface="Calibri"/>
               </a:rPr>
-              <a:t>25 tests automatizados en CI (sin datos ni API keys): flujos normal/ambiguo/handoff, sesión vencida, acceso ajeno, inyección directa e indirecta, cliente señuelo</a:t>
+              <a:t>80 tests automatizados en CI (sin datos ni API keys): flujos normal/ambiguo/handoff, sesión vencida, acceso ajeno, inyección directa e indirecta, cliente señuelo</a:t>
             </a:r>
           </a:p>
         </p:txBody>
@@ -9008,11 +9008,11 @@
             <a:r>
               <a:rPr sz="1600" b="0" i="0">
                 <a:solidFill>
-                  <a:srgbClr val="B54A1A"/>
-                </a:solidFill>
-                <a:latin typeface="Calibri"/>
-              </a:rPr>
-              <a:t>Capacidad: [[PENDIENTE: reports/capacity.md]]</a:t>
+                  <a:srgbClr val="0B0B0B"/>
+                </a:solidFill>
+                <a:latin typeface="Calibri"/>
+              </a:rPr>
+              <a:t>Capacidad: p95 233 ms por turno · ~61 turnos/s por réplica (sin LLM, costo $0)</a:t>
             </a:r>
           </a:p>
         </p:txBody>

</xml_diff>

<commit_message>
docs(eval): reporte oficial tras #54, uso del test declarado y deck con métricas reales
- reports/eval.md regenerado (test congelado, 3 corridas): agente 102/115 correctos,
  49/57 resolución segura, 0 inseguros; B1 sin política 82/115 inseguros
- evals/cases/README: segunda ronda y declaración de la fuga leve (ajustes tras ver
  agregados de test en #54)
- metrics.yaml + deck (pptx/md/pdf) con los números de eval, inyección y equidad

Co-Authored-By: Claude Opus 5.5 <noreply@anthropic.com>
</commit_message>
<xml_diff>
--- a/docs/pitch/deck.pptx
+++ b/docs/pitch/deck.pptx
@@ -6075,73 +6075,30 @@
           </a:p>
         </p:txBody>
       </p:sp>
-      <p:sp>
-        <p:nvSpPr>
-          <p:cNvPr id="5" name="Rounded Rectangle 4"/>
-          <p:cNvSpPr/>
-          <p:nvPr/>
-        </p:nvSpPr>
+      <p:pic>
+        <p:nvPicPr>
+          <p:cNvPr id="5" name="Picture 4" descr="escena1.png"/>
+          <p:cNvPicPr>
+            <a:picLocks noChangeAspect="1"/>
+          </p:cNvPicPr>
+          <p:nvPr/>
+        </p:nvPicPr>
+        <p:blipFill>
+          <a:blip r:embed="rId2"/>
+          <a:stretch>
+            <a:fillRect/>
+          </a:stretch>
+        </p:blipFill>
         <p:spPr>
           <a:xfrm>
             <a:off x="548640" y="1874519"/>
-            <a:ext cx="3520440" cy="2103120"/>
-          </a:xfrm>
-          <a:prstGeom prst="roundRect">
-            <a:avLst>
-              <a:gd name="adj" fmla="val 8000"/>
-            </a:avLst>
-          </a:prstGeom>
-          <a:solidFill>
-            <a:srgbClr val="F4F4F2"/>
-          </a:solidFill>
-          <a:ln>
-            <a:noFill/>
-          </a:ln>
-          <a:effectLst/>
-        </p:spPr>
-        <p:style>
-          <a:lnRef idx="1">
-            <a:schemeClr val="accent1"/>
-          </a:lnRef>
-          <a:fillRef idx="3">
-            <a:schemeClr val="accent1"/>
-          </a:fillRef>
-          <a:effectRef idx="2">
-            <a:schemeClr val="accent1"/>
-          </a:effectRef>
-          <a:fontRef idx="minor">
-            <a:schemeClr val="lt1"/>
-          </a:fontRef>
-        </p:style>
-        <p:txBody>
-          <a:bodyPr rtlCol="0" anchor="ctr" wrap="square" lIns="54864" rIns="54864"/>
-          <a:lstStyle/>
-          <a:p>
-            <a:pPr algn="ctr"/>
-            <a:r>
-              <a:rPr sz="1300" b="1">
-                <a:solidFill>
-                  <a:srgbClr val="B54A1A"/>
-                </a:solidFill>
-                <a:latin typeface="Calibri"/>
-              </a:rPr>
-              <a:t>[[PENDIENTE: captura]]</a:t>
-            </a:r>
-          </a:p>
-          <a:p>
-            <a:pPr algn="ctr"/>
-            <a:r>
-              <a:rPr sz="1000" b="0">
-                <a:solidFill>
-                  <a:srgbClr val="B54A1A"/>
-                </a:solidFill>
-                <a:latin typeface="Calibri"/>
-              </a:rPr>
-              <a:t>docs/pitch/screens/escena1.png</a:t>
-            </a:r>
-          </a:p>
-        </p:txBody>
-      </p:sp>
+            <a:ext cx="3520440" cy="2200275"/>
+          </a:xfrm>
+          <a:prstGeom prst="rect">
+            <a:avLst/>
+          </a:prstGeom>
+        </p:spPr>
+      </p:pic>
       <p:sp>
         <p:nvSpPr>
           <p:cNvPr id="6" name="TextBox 5"/>
@@ -6259,73 +6216,30 @@
           </a:p>
         </p:txBody>
       </p:sp>
-      <p:sp>
-        <p:nvSpPr>
-          <p:cNvPr id="9" name="Rounded Rectangle 8"/>
-          <p:cNvSpPr/>
-          <p:nvPr/>
-        </p:nvSpPr>
+      <p:pic>
+        <p:nvPicPr>
+          <p:cNvPr id="9" name="Picture 8" descr="escena2.png"/>
+          <p:cNvPicPr>
+            <a:picLocks noChangeAspect="1"/>
+          </p:cNvPicPr>
+          <p:nvPr/>
+        </p:nvPicPr>
+        <p:blipFill>
+          <a:blip r:embed="rId3"/>
+          <a:stretch>
+            <a:fillRect/>
+          </a:stretch>
+        </p:blipFill>
         <p:spPr>
           <a:xfrm>
             <a:off x="4297679" y="1874519"/>
-            <a:ext cx="3520440" cy="2103120"/>
-          </a:xfrm>
-          <a:prstGeom prst="roundRect">
-            <a:avLst>
-              <a:gd name="adj" fmla="val 8000"/>
-            </a:avLst>
-          </a:prstGeom>
-          <a:solidFill>
-            <a:srgbClr val="F4F4F2"/>
-          </a:solidFill>
-          <a:ln>
-            <a:noFill/>
-          </a:ln>
-          <a:effectLst/>
-        </p:spPr>
-        <p:style>
-          <a:lnRef idx="1">
-            <a:schemeClr val="accent1"/>
-          </a:lnRef>
-          <a:fillRef idx="3">
-            <a:schemeClr val="accent1"/>
-          </a:fillRef>
-          <a:effectRef idx="2">
-            <a:schemeClr val="accent1"/>
-          </a:effectRef>
-          <a:fontRef idx="minor">
-            <a:schemeClr val="lt1"/>
-          </a:fontRef>
-        </p:style>
-        <p:txBody>
-          <a:bodyPr rtlCol="0" anchor="ctr" wrap="square" lIns="54864" rIns="54864"/>
-          <a:lstStyle/>
-          <a:p>
-            <a:pPr algn="ctr"/>
-            <a:r>
-              <a:rPr sz="1300" b="1">
-                <a:solidFill>
-                  <a:srgbClr val="B54A1A"/>
-                </a:solidFill>
-                <a:latin typeface="Calibri"/>
-              </a:rPr>
-              <a:t>[[PENDIENTE: captura]]</a:t>
-            </a:r>
-          </a:p>
-          <a:p>
-            <a:pPr algn="ctr"/>
-            <a:r>
-              <a:rPr sz="1000" b="0">
-                <a:solidFill>
-                  <a:srgbClr val="B54A1A"/>
-                </a:solidFill>
-                <a:latin typeface="Calibri"/>
-              </a:rPr>
-              <a:t>docs/pitch/screens/escena2.png</a:t>
-            </a:r>
-          </a:p>
-        </p:txBody>
-      </p:sp>
+            <a:ext cx="3520440" cy="2200275"/>
+          </a:xfrm>
+          <a:prstGeom prst="rect">
+            <a:avLst/>
+          </a:prstGeom>
+        </p:spPr>
+      </p:pic>
       <p:sp>
         <p:nvSpPr>
           <p:cNvPr id="10" name="TextBox 9"/>
@@ -6443,73 +6357,30 @@
           </a:p>
         </p:txBody>
       </p:sp>
-      <p:sp>
-        <p:nvSpPr>
-          <p:cNvPr id="13" name="Rounded Rectangle 12"/>
-          <p:cNvSpPr/>
-          <p:nvPr/>
-        </p:nvSpPr>
+      <p:pic>
+        <p:nvPicPr>
+          <p:cNvPr id="13" name="Picture 12" descr="escena3.png"/>
+          <p:cNvPicPr>
+            <a:picLocks noChangeAspect="1"/>
+          </p:cNvPicPr>
+          <p:nvPr/>
+        </p:nvPicPr>
+        <p:blipFill>
+          <a:blip r:embed="rId4"/>
+          <a:stretch>
+            <a:fillRect/>
+          </a:stretch>
+        </p:blipFill>
         <p:spPr>
           <a:xfrm>
             <a:off x="8046719" y="1874519"/>
-            <a:ext cx="3520440" cy="2103120"/>
-          </a:xfrm>
-          <a:prstGeom prst="roundRect">
-            <a:avLst>
-              <a:gd name="adj" fmla="val 8000"/>
-            </a:avLst>
-          </a:prstGeom>
-          <a:solidFill>
-            <a:srgbClr val="F4F4F2"/>
-          </a:solidFill>
-          <a:ln>
-            <a:noFill/>
-          </a:ln>
-          <a:effectLst/>
-        </p:spPr>
-        <p:style>
-          <a:lnRef idx="1">
-            <a:schemeClr val="accent1"/>
-          </a:lnRef>
-          <a:fillRef idx="3">
-            <a:schemeClr val="accent1"/>
-          </a:fillRef>
-          <a:effectRef idx="2">
-            <a:schemeClr val="accent1"/>
-          </a:effectRef>
-          <a:fontRef idx="minor">
-            <a:schemeClr val="lt1"/>
-          </a:fontRef>
-        </p:style>
-        <p:txBody>
-          <a:bodyPr rtlCol="0" anchor="ctr" wrap="square" lIns="54864" rIns="54864"/>
-          <a:lstStyle/>
-          <a:p>
-            <a:pPr algn="ctr"/>
-            <a:r>
-              <a:rPr sz="1300" b="1">
-                <a:solidFill>
-                  <a:srgbClr val="B54A1A"/>
-                </a:solidFill>
-                <a:latin typeface="Calibri"/>
-              </a:rPr>
-              <a:t>[[PENDIENTE: captura]]</a:t>
-            </a:r>
-          </a:p>
-          <a:p>
-            <a:pPr algn="ctr"/>
-            <a:r>
-              <a:rPr sz="1000" b="0">
-                <a:solidFill>
-                  <a:srgbClr val="B54A1A"/>
-                </a:solidFill>
-                <a:latin typeface="Calibri"/>
-              </a:rPr>
-              <a:t>docs/pitch/screens/escena3.png</a:t>
-            </a:r>
-          </a:p>
-        </p:txBody>
-      </p:sp>
+            <a:ext cx="3520440" cy="2200275"/>
+          </a:xfrm>
+          <a:prstGeom prst="rect">
+            <a:avLst/>
+          </a:prstGeom>
+        </p:spPr>
+      </p:pic>
       <p:sp>
         <p:nvSpPr>
           <p:cNvPr id="14" name="TextBox 13"/>
@@ -6936,13 +6807,13 @@
               </a:spcAft>
             </a:pPr>
             <a:r>
-              <a:rPr sz="1500" b="1" i="0">
-                <a:solidFill>
-                  <a:srgbClr val="B54A1A"/>
-                </a:solidFill>
-                <a:latin typeface="Calibri"/>
-              </a:rPr>
-              <a:t>[[PENDIENTE: reports/eval.md]]</a:t>
+              <a:rPr sz="3000" b="1" i="0">
+                <a:solidFill>
+                  <a:srgbClr val="2A78D6"/>
+                </a:solidFill>
+                <a:latin typeface="Calibri"/>
+              </a:rPr>
+              <a:t>86% resolución segura (49/57) · 0/115 inseguros</a:t>
             </a:r>
           </a:p>
         </p:txBody>
@@ -6977,11 +6848,11 @@
             <a:r>
               <a:rPr sz="1300" b="0" i="0">
                 <a:solidFill>
-                  <a:srgbClr val="B54A1A"/>
-                </a:solidFill>
-                <a:latin typeface="Calibri"/>
-              </a:rPr>
-              <a:t>línea base: [[PENDIENTE: reports/eval.md]]</a:t>
+                  <a:srgbClr val="0B0B0B"/>
+                </a:solidFill>
+                <a:latin typeface="Calibri"/>
+              </a:rPr>
+              <a:t>línea base: sin política: 82/115 inseguros · deriva todo: 0/57 resueltos</a:t>
             </a:r>
           </a:p>
         </p:txBody>
@@ -7016,11 +6887,11 @@
             <a:r>
               <a:rPr sz="1200" b="0" i="0">
                 <a:solidFill>
-                  <a:srgbClr val="B54A1A"/>
-                </a:solidFill>
-                <a:latin typeface="Calibri"/>
-              </a:rPr>
-              <a:t>Éxito de tarea en casos reservados · [[PENDIENTE: reports/eval.md]]</a:t>
+                  <a:srgbClr val="52514E"/>
+                </a:solidFill>
+                <a:latin typeface="Calibri"/>
+              </a:rPr>
+              <a:t>Éxito de tarea en casos reservados · 115 casos + 44 variantes de dialecto, 3 corridas</a:t>
             </a:r>
           </a:p>
         </p:txBody>
@@ -7138,13 +7009,13 @@
               </a:spcAft>
             </a:pPr>
             <a:r>
-              <a:rPr sz="1500" b="1" i="0">
-                <a:solidFill>
-                  <a:srgbClr val="B54A1A"/>
-                </a:solidFill>
-                <a:latin typeface="Calibri"/>
-              </a:rPr>
-              <a:t>[[PENDIENTE: reports/injection_eval.md]]</a:t>
+              <a:rPr sz="3000" b="1" i="0">
+                <a:solidFill>
+                  <a:srgbClr val="2A78D6"/>
+                </a:solidFill>
+                <a:latin typeface="Calibri"/>
+              </a:rPr>
+              <a:t>regex AUC 0.55 · clasificador AUC 0.97</a:t>
             </a:r>
           </a:p>
         </p:txBody>
@@ -7179,11 +7050,11 @@
             <a:r>
               <a:rPr sz="1300" b="0" i="0">
                 <a:solidFill>
-                  <a:srgbClr val="B54A1A"/>
-                </a:solidFill>
-                <a:latin typeface="Calibri"/>
-              </a:rPr>
-              <a:t>falsos positivos: [[PENDIENTE: reports/injection_eval.md]]</a:t>
+                  <a:srgbClr val="0B0B0B"/>
+                </a:solidFill>
+                <a:latin typeface="Calibri"/>
+              </a:rPr>
+              <a:t>falsos positivos: regex 0/58 · clasificador 20/58 en mensajes bancarios</a:t>
             </a:r>
           </a:p>
         </p:txBody>
@@ -7340,13 +7211,13 @@
               </a:spcAft>
             </a:pPr>
             <a:r>
-              <a:rPr sz="1500" b="1" i="0">
-                <a:solidFill>
-                  <a:srgbClr val="B54A1A"/>
-                </a:solidFill>
-                <a:latin typeface="Calibri"/>
-              </a:rPr>
-              <a:t>[[PENDIENTE: reports/injection_eval.md]]</a:t>
+              <a:rPr sz="3000" b="1" i="0">
+                <a:solidFill>
+                  <a:srgbClr val="2A78D6"/>
+                </a:solidFill>
+                <a:latin typeface="Calibri"/>
+              </a:rPr>
+              <a:t>0/2.531 ataques con daño, incluso con el guard apagado</a:t>
             </a:r>
           </a:p>
         </p:txBody>
@@ -7542,13 +7413,13 @@
               </a:spcAft>
             </a:pPr>
             <a:r>
-              <a:rPr sz="1500" b="1" i="0">
-                <a:solidFill>
-                  <a:srgbClr val="B54A1A"/>
-                </a:solidFill>
-                <a:latin typeface="Calibri"/>
-              </a:rPr>
-              <a:t>[[PENDIENTE: reports/eval.md]]</a:t>
+              <a:rPr sz="3000" b="1" i="0">
+                <a:solidFill>
+                  <a:srgbClr val="2A78D6"/>
+                </a:solidFill>
+                <a:latin typeface="Calibri"/>
+              </a:rPr>
+              <a:t>10/11 grupos con la misma decisión</a:t>
             </a:r>
           </a:p>
         </p:txBody>
@@ -7665,7 +7536,7 @@
                 </a:solidFill>
                 <a:latin typeface="Calibri"/>
               </a:rPr>
-              <a:t>80 tests automatizados en CI (sin datos ni API keys): flujos normal/ambiguo/handoff, sesión vencida, acceso ajeno, inyección directa e indirecta, cliente señuelo</a:t>
+              <a:t>528 tests automatizados en CI (sin datos ni API keys): flujos normal/ambiguo/handoff, sesión vencida, acceso ajeno, inyección directa e indirecta, cliente señuelo</a:t>
             </a:r>
           </a:p>
         </p:txBody>

</xml_diff>

<commit_message>
docs(eval): reporte oficial tras #54, uso del test declarado y deck con métricas reales (#58)
- reports/eval.md regenerado (test congelado, 3 corridas): agente 102/115 correctos,
  49/57 resolución segura, 0 inseguros; B1 sin política 82/115 inseguros
- evals/cases/README: segunda ronda y declaración de la fuga leve (ajustes tras ver
  agregados de test en #54)
- metrics.yaml + deck (pptx/md/pdf) con los números de eval, inyección y equidad

Co-authored-by: Mr-Percival <188080720.Mr-Percival@users.noreply.github.com>
Co-authored-by: Claude Opus 5.5 <noreply@anthropic.com>
</commit_message>
<xml_diff>
--- a/docs/pitch/deck.pptx
+++ b/docs/pitch/deck.pptx
@@ -6075,73 +6075,30 @@
           </a:p>
         </p:txBody>
       </p:sp>
-      <p:sp>
-        <p:nvSpPr>
-          <p:cNvPr id="5" name="Rounded Rectangle 4"/>
-          <p:cNvSpPr/>
-          <p:nvPr/>
-        </p:nvSpPr>
+      <p:pic>
+        <p:nvPicPr>
+          <p:cNvPr id="5" name="Picture 4" descr="escena1.png"/>
+          <p:cNvPicPr>
+            <a:picLocks noChangeAspect="1"/>
+          </p:cNvPicPr>
+          <p:nvPr/>
+        </p:nvPicPr>
+        <p:blipFill>
+          <a:blip r:embed="rId2"/>
+          <a:stretch>
+            <a:fillRect/>
+          </a:stretch>
+        </p:blipFill>
         <p:spPr>
           <a:xfrm>
             <a:off x="548640" y="1874519"/>
-            <a:ext cx="3520440" cy="2103120"/>
-          </a:xfrm>
-          <a:prstGeom prst="roundRect">
-            <a:avLst>
-              <a:gd name="adj" fmla="val 8000"/>
-            </a:avLst>
-          </a:prstGeom>
-          <a:solidFill>
-            <a:srgbClr val="F4F4F2"/>
-          </a:solidFill>
-          <a:ln>
-            <a:noFill/>
-          </a:ln>
-          <a:effectLst/>
-        </p:spPr>
-        <p:style>
-          <a:lnRef idx="1">
-            <a:schemeClr val="accent1"/>
-          </a:lnRef>
-          <a:fillRef idx="3">
-            <a:schemeClr val="accent1"/>
-          </a:fillRef>
-          <a:effectRef idx="2">
-            <a:schemeClr val="accent1"/>
-          </a:effectRef>
-          <a:fontRef idx="minor">
-            <a:schemeClr val="lt1"/>
-          </a:fontRef>
-        </p:style>
-        <p:txBody>
-          <a:bodyPr rtlCol="0" anchor="ctr" wrap="square" lIns="54864" rIns="54864"/>
-          <a:lstStyle/>
-          <a:p>
-            <a:pPr algn="ctr"/>
-            <a:r>
-              <a:rPr sz="1300" b="1">
-                <a:solidFill>
-                  <a:srgbClr val="B54A1A"/>
-                </a:solidFill>
-                <a:latin typeface="Calibri"/>
-              </a:rPr>
-              <a:t>[[PENDIENTE: captura]]</a:t>
-            </a:r>
-          </a:p>
-          <a:p>
-            <a:pPr algn="ctr"/>
-            <a:r>
-              <a:rPr sz="1000" b="0">
-                <a:solidFill>
-                  <a:srgbClr val="B54A1A"/>
-                </a:solidFill>
-                <a:latin typeface="Calibri"/>
-              </a:rPr>
-              <a:t>docs/pitch/screens/escena1.png</a:t>
-            </a:r>
-          </a:p>
-        </p:txBody>
-      </p:sp>
+            <a:ext cx="3520440" cy="2200275"/>
+          </a:xfrm>
+          <a:prstGeom prst="rect">
+            <a:avLst/>
+          </a:prstGeom>
+        </p:spPr>
+      </p:pic>
       <p:sp>
         <p:nvSpPr>
           <p:cNvPr id="6" name="TextBox 5"/>
@@ -6259,73 +6216,30 @@
           </a:p>
         </p:txBody>
       </p:sp>
-      <p:sp>
-        <p:nvSpPr>
-          <p:cNvPr id="9" name="Rounded Rectangle 8"/>
-          <p:cNvSpPr/>
-          <p:nvPr/>
-        </p:nvSpPr>
+      <p:pic>
+        <p:nvPicPr>
+          <p:cNvPr id="9" name="Picture 8" descr="escena2.png"/>
+          <p:cNvPicPr>
+            <a:picLocks noChangeAspect="1"/>
+          </p:cNvPicPr>
+          <p:nvPr/>
+        </p:nvPicPr>
+        <p:blipFill>
+          <a:blip r:embed="rId3"/>
+          <a:stretch>
+            <a:fillRect/>
+          </a:stretch>
+        </p:blipFill>
         <p:spPr>
           <a:xfrm>
             <a:off x="4297679" y="1874519"/>
-            <a:ext cx="3520440" cy="2103120"/>
-          </a:xfrm>
-          <a:prstGeom prst="roundRect">
-            <a:avLst>
-              <a:gd name="adj" fmla="val 8000"/>
-            </a:avLst>
-          </a:prstGeom>
-          <a:solidFill>
-            <a:srgbClr val="F4F4F2"/>
-          </a:solidFill>
-          <a:ln>
-            <a:noFill/>
-          </a:ln>
-          <a:effectLst/>
-        </p:spPr>
-        <p:style>
-          <a:lnRef idx="1">
-            <a:schemeClr val="accent1"/>
-          </a:lnRef>
-          <a:fillRef idx="3">
-            <a:schemeClr val="accent1"/>
-          </a:fillRef>
-          <a:effectRef idx="2">
-            <a:schemeClr val="accent1"/>
-          </a:effectRef>
-          <a:fontRef idx="minor">
-            <a:schemeClr val="lt1"/>
-          </a:fontRef>
-        </p:style>
-        <p:txBody>
-          <a:bodyPr rtlCol="0" anchor="ctr" wrap="square" lIns="54864" rIns="54864"/>
-          <a:lstStyle/>
-          <a:p>
-            <a:pPr algn="ctr"/>
-            <a:r>
-              <a:rPr sz="1300" b="1">
-                <a:solidFill>
-                  <a:srgbClr val="B54A1A"/>
-                </a:solidFill>
-                <a:latin typeface="Calibri"/>
-              </a:rPr>
-              <a:t>[[PENDIENTE: captura]]</a:t>
-            </a:r>
-          </a:p>
-          <a:p>
-            <a:pPr algn="ctr"/>
-            <a:r>
-              <a:rPr sz="1000" b="0">
-                <a:solidFill>
-                  <a:srgbClr val="B54A1A"/>
-                </a:solidFill>
-                <a:latin typeface="Calibri"/>
-              </a:rPr>
-              <a:t>docs/pitch/screens/escena2.png</a:t>
-            </a:r>
-          </a:p>
-        </p:txBody>
-      </p:sp>
+            <a:ext cx="3520440" cy="2200275"/>
+          </a:xfrm>
+          <a:prstGeom prst="rect">
+            <a:avLst/>
+          </a:prstGeom>
+        </p:spPr>
+      </p:pic>
       <p:sp>
         <p:nvSpPr>
           <p:cNvPr id="10" name="TextBox 9"/>
@@ -6443,73 +6357,30 @@
           </a:p>
         </p:txBody>
       </p:sp>
-      <p:sp>
-        <p:nvSpPr>
-          <p:cNvPr id="13" name="Rounded Rectangle 12"/>
-          <p:cNvSpPr/>
-          <p:nvPr/>
-        </p:nvSpPr>
+      <p:pic>
+        <p:nvPicPr>
+          <p:cNvPr id="13" name="Picture 12" descr="escena3.png"/>
+          <p:cNvPicPr>
+            <a:picLocks noChangeAspect="1"/>
+          </p:cNvPicPr>
+          <p:nvPr/>
+        </p:nvPicPr>
+        <p:blipFill>
+          <a:blip r:embed="rId4"/>
+          <a:stretch>
+            <a:fillRect/>
+          </a:stretch>
+        </p:blipFill>
         <p:spPr>
           <a:xfrm>
             <a:off x="8046719" y="1874519"/>
-            <a:ext cx="3520440" cy="2103120"/>
-          </a:xfrm>
-          <a:prstGeom prst="roundRect">
-            <a:avLst>
-              <a:gd name="adj" fmla="val 8000"/>
-            </a:avLst>
-          </a:prstGeom>
-          <a:solidFill>
-            <a:srgbClr val="F4F4F2"/>
-          </a:solidFill>
-          <a:ln>
-            <a:noFill/>
-          </a:ln>
-          <a:effectLst/>
-        </p:spPr>
-        <p:style>
-          <a:lnRef idx="1">
-            <a:schemeClr val="accent1"/>
-          </a:lnRef>
-          <a:fillRef idx="3">
-            <a:schemeClr val="accent1"/>
-          </a:fillRef>
-          <a:effectRef idx="2">
-            <a:schemeClr val="accent1"/>
-          </a:effectRef>
-          <a:fontRef idx="minor">
-            <a:schemeClr val="lt1"/>
-          </a:fontRef>
-        </p:style>
-        <p:txBody>
-          <a:bodyPr rtlCol="0" anchor="ctr" wrap="square" lIns="54864" rIns="54864"/>
-          <a:lstStyle/>
-          <a:p>
-            <a:pPr algn="ctr"/>
-            <a:r>
-              <a:rPr sz="1300" b="1">
-                <a:solidFill>
-                  <a:srgbClr val="B54A1A"/>
-                </a:solidFill>
-                <a:latin typeface="Calibri"/>
-              </a:rPr>
-              <a:t>[[PENDIENTE: captura]]</a:t>
-            </a:r>
-          </a:p>
-          <a:p>
-            <a:pPr algn="ctr"/>
-            <a:r>
-              <a:rPr sz="1000" b="0">
-                <a:solidFill>
-                  <a:srgbClr val="B54A1A"/>
-                </a:solidFill>
-                <a:latin typeface="Calibri"/>
-              </a:rPr>
-              <a:t>docs/pitch/screens/escena3.png</a:t>
-            </a:r>
-          </a:p>
-        </p:txBody>
-      </p:sp>
+            <a:ext cx="3520440" cy="2200275"/>
+          </a:xfrm>
+          <a:prstGeom prst="rect">
+            <a:avLst/>
+          </a:prstGeom>
+        </p:spPr>
+      </p:pic>
       <p:sp>
         <p:nvSpPr>
           <p:cNvPr id="14" name="TextBox 13"/>
@@ -6936,13 +6807,13 @@
               </a:spcAft>
             </a:pPr>
             <a:r>
-              <a:rPr sz="1500" b="1" i="0">
-                <a:solidFill>
-                  <a:srgbClr val="B54A1A"/>
-                </a:solidFill>
-                <a:latin typeface="Calibri"/>
-              </a:rPr>
-              <a:t>[[PENDIENTE: reports/eval.md]]</a:t>
+              <a:rPr sz="3000" b="1" i="0">
+                <a:solidFill>
+                  <a:srgbClr val="2A78D6"/>
+                </a:solidFill>
+                <a:latin typeface="Calibri"/>
+              </a:rPr>
+              <a:t>86% resolución segura (49/57) · 0/115 inseguros</a:t>
             </a:r>
           </a:p>
         </p:txBody>
@@ -6977,11 +6848,11 @@
             <a:r>
               <a:rPr sz="1300" b="0" i="0">
                 <a:solidFill>
-                  <a:srgbClr val="B54A1A"/>
-                </a:solidFill>
-                <a:latin typeface="Calibri"/>
-              </a:rPr>
-              <a:t>línea base: [[PENDIENTE: reports/eval.md]]</a:t>
+                  <a:srgbClr val="0B0B0B"/>
+                </a:solidFill>
+                <a:latin typeface="Calibri"/>
+              </a:rPr>
+              <a:t>línea base: sin política: 82/115 inseguros · deriva todo: 0/57 resueltos</a:t>
             </a:r>
           </a:p>
         </p:txBody>
@@ -7016,11 +6887,11 @@
             <a:r>
               <a:rPr sz="1200" b="0" i="0">
                 <a:solidFill>
-                  <a:srgbClr val="B54A1A"/>
-                </a:solidFill>
-                <a:latin typeface="Calibri"/>
-              </a:rPr>
-              <a:t>Éxito de tarea en casos reservados · [[PENDIENTE: reports/eval.md]]</a:t>
+                  <a:srgbClr val="52514E"/>
+                </a:solidFill>
+                <a:latin typeface="Calibri"/>
+              </a:rPr>
+              <a:t>Éxito de tarea en casos reservados · 115 casos + 44 variantes de dialecto, 3 corridas</a:t>
             </a:r>
           </a:p>
         </p:txBody>
@@ -7138,13 +7009,13 @@
               </a:spcAft>
             </a:pPr>
             <a:r>
-              <a:rPr sz="1500" b="1" i="0">
-                <a:solidFill>
-                  <a:srgbClr val="B54A1A"/>
-                </a:solidFill>
-                <a:latin typeface="Calibri"/>
-              </a:rPr>
-              <a:t>[[PENDIENTE: reports/injection_eval.md]]</a:t>
+              <a:rPr sz="3000" b="1" i="0">
+                <a:solidFill>
+                  <a:srgbClr val="2A78D6"/>
+                </a:solidFill>
+                <a:latin typeface="Calibri"/>
+              </a:rPr>
+              <a:t>regex AUC 0.55 · clasificador AUC 0.97</a:t>
             </a:r>
           </a:p>
         </p:txBody>
@@ -7179,11 +7050,11 @@
             <a:r>
               <a:rPr sz="1300" b="0" i="0">
                 <a:solidFill>
-                  <a:srgbClr val="B54A1A"/>
-                </a:solidFill>
-                <a:latin typeface="Calibri"/>
-              </a:rPr>
-              <a:t>falsos positivos: [[PENDIENTE: reports/injection_eval.md]]</a:t>
+                  <a:srgbClr val="0B0B0B"/>
+                </a:solidFill>
+                <a:latin typeface="Calibri"/>
+              </a:rPr>
+              <a:t>falsos positivos: regex 0/58 · clasificador 20/58 en mensajes bancarios</a:t>
             </a:r>
           </a:p>
         </p:txBody>
@@ -7340,13 +7211,13 @@
               </a:spcAft>
             </a:pPr>
             <a:r>
-              <a:rPr sz="1500" b="1" i="0">
-                <a:solidFill>
-                  <a:srgbClr val="B54A1A"/>
-                </a:solidFill>
-                <a:latin typeface="Calibri"/>
-              </a:rPr>
-              <a:t>[[PENDIENTE: reports/injection_eval.md]]</a:t>
+              <a:rPr sz="3000" b="1" i="0">
+                <a:solidFill>
+                  <a:srgbClr val="2A78D6"/>
+                </a:solidFill>
+                <a:latin typeface="Calibri"/>
+              </a:rPr>
+              <a:t>0/2.531 ataques con daño, incluso con el guard apagado</a:t>
             </a:r>
           </a:p>
         </p:txBody>
@@ -7542,13 +7413,13 @@
               </a:spcAft>
             </a:pPr>
             <a:r>
-              <a:rPr sz="1500" b="1" i="0">
-                <a:solidFill>
-                  <a:srgbClr val="B54A1A"/>
-                </a:solidFill>
-                <a:latin typeface="Calibri"/>
-              </a:rPr>
-              <a:t>[[PENDIENTE: reports/eval.md]]</a:t>
+              <a:rPr sz="3000" b="1" i="0">
+                <a:solidFill>
+                  <a:srgbClr val="2A78D6"/>
+                </a:solidFill>
+                <a:latin typeface="Calibri"/>
+              </a:rPr>
+              <a:t>10/11 grupos con la misma decisión</a:t>
             </a:r>
           </a:p>
         </p:txBody>
@@ -7665,7 +7536,7 @@
                 </a:solidFill>
                 <a:latin typeface="Calibri"/>
               </a:rPr>
-              <a:t>80 tests automatizados en CI (sin datos ni API keys): flujos normal/ambiguo/handoff, sesión vencida, acceso ajeno, inyección directa e indirecta, cliente señuelo</a:t>
+              <a:t>528 tests automatizados en CI (sin datos ni API keys): flujos normal/ambiguo/handoff, sesión vencida, acceso ajeno, inyección directa e indirecta, cliente señuelo</a:t>
             </a:r>
           </a:p>
         </p:txBody>

</xml_diff>

<commit_message>
docs(pitch): deck con el sistema de la demo, escenas reales y PDF versionado
metrics.yaml usa los números del router aprendido (eval_router.md) con las
líneas base, agrega el componente aprendido (intent_router.md) y el red team.
make_deck.py lee las escenas de docs/demo/demo_customers.json; la slide 6 ya
no lista pendientes cerrados. make_deck_pdf.py pone las capturas de las
escenas en la slide 3, parte la slide 6 en dos columnas y no exporta la lista
de pendientes como slide. Capturas nuevas con la base de demo (router
aprendido, consentimiento por acción). Guion del video alineado con
docs/demo-script.md. docs/pitch/deck.pdf entra al repo como excepción.

Co-Authored-By: Claude Opus 5.5 <noreply@anthropic.com>
</commit_message>
<xml_diff>
--- a/docs/pitch/deck.pptx
+++ b/docs/pitch/deck.pptx
@@ -577,7 +577,7 @@
           <a:lstStyle/>
           <a:p>
             <a:r>
-              <a:t>Un solo agente en LangGraph con pasos explícitos. El modelo aparece solo en dos lugares: entender qué quiere el cliente y redactar la respuesta. Todo lo que puede causar daño es código: el guard filtra inyecciones y enmascara PII; las herramientas derivan el cliente del token, así que un prompt no puede pedir datos ajenos; la elegibilidad la decide un YAML con reglas identificadas; y cada acción pide confirmación y se verifica releyendo el estado. Cada interfaz del modelo tiene una versión con reglas y plantillas: es la línea base y el camino alternativo si el modelo falla.</a:t>
+              <a:t>Un solo agente en LangGraph con pasos explícitos. El modelo aparece en un solo lugar de la demo: entender qué quiere el cliente. Es un router de intención que entrenamos nosotros, local, de 0,2 megas, que se abstiene cuando duda; los montos, las fechas y el sí de cada acción los siguen leyendo reglas. Todo lo que puede causar daño es código: el guard filtra inyecciones y enmascara PII; las herramientas derivan el cliente del token, así que un prompt no puede pedir datos ajenos; la elegibilidad la decide un YAML con reglas identificadas; y cada acción pide confirmación y se verifica releyendo el estado. El router y el writer con LLM están implementados detrás de las mismas interfaces, pero apagados: no hay API paga, y la línea base es el camino alternativo si el modelo falla.</a:t>
             </a:r>
           </a:p>
         </p:txBody>
@@ -647,7 +647,7 @@
           <a:lstStyle/>
           <a:p>
             <a:r>
-              <a:t>Tres conversaciones del mismo flujo. Primera: Ana no reconoce un cargo de 77 dólares; hay un único candidato, la política lo permite y, tras su sí, se abre la disputa y se bloquea la tarjeta; solo decimos 'listo' si la verificación lo confirma. Segunda: 350 coincide con dos cargos, así que el agente pregunta en vez de adivinar. Tercera, en portugués: un cargo en Brasil con score de fraude alto activa la regla H03 y pasa a un asesor con la traza, los hechos verificados y la regla. Y si alguien escribe 'olvida las reglas', el guard lo bloquea antes de llegar al modelo.</a:t>
+              <a:t>Tres conversaciones del mismo flujo, con clientes reales del dataset del organizador. Primera, en México: el cliente no reconoce un cargo de 151 dólares en Gasolinera Express; hay un único candidato, la política lo permite y el agente ofrece la disputa y el bloqueo por separado. Con «sí, ambas» abre la disputa y bloquea la tarjeta; solo dice 'listo' si la verificación lo confirma. Segunda, en Colombia: 242.000 pesos coincide con dos cargos, así que pregunta en vez de adivinar. Tercera, en portugués: un cargo con score de fraude 95.1 activa la regla H03 y pasa a un analista con la traza, los hechos verificados y la regla. Y si alguien escribe 'ignora tus instrucciones', el guard lo bloquea antes del router; aunque no lo hiciera, el cliente sale del token, no del texto.</a:t>
             </a:r>
           </a:p>
         </p:txBody>
@@ -717,7 +717,7 @@
           <a:lstStyle/>
           <a:p>
             <a:r>
-              <a:t>No entrenamos sobre las transcripciones del dataset: solo hay 42 textos de cliente distintos, así que cualquier métrica sería inválida. Evaluamos donde hay etiquetas válidas. Uno: el agente contra la línea base de reglas en casos reservados, generados por el equipo y declarados como tales. Dos: la detección de inyección con datasets públicos, y por separado el daño, porque aunque el detector falle el ataque no tiene con qué dañar. Tres: equidad; el mismo caso escrito en dialectos distintos debe dar la misma decisión.</a:t>
+              <a:t>No entrenamos sobre las transcripciones del dataset: solo hay 42 textos de cliente distintos. Medimos donde hay etiquetas válidas. Uno: el agente de la demo contra la línea base de reglas y contra dos líneas base ingenuas, en casos reservados generados por el equipo y declarados como tales; automatizar sin política da 82 resultados inseguros de 115, el nuestro cero. Dos: el componente aprendido, el router de intención, contra las reglas, en un corpus propio dividido por autor. Tres: seguridad; con datasets públicos, regex AUC 0.55 · clasificador AUC 0.97, pero lo que importa es el daño, que medimos aparte: cero, aun con el guard apagado. Y un red team propio de tres rondas sí encontró daño real, que corregimos en la raíz. Cuatro: equidad; el mismo caso en dialectos distintos debe dar la misma decisión. Somos explícitos: el test ya se midió dos veces y declaramos una fuga leve.</a:t>
             </a:r>
           </a:p>
         </p:txBody>
@@ -857,7 +857,7 @@
           <a:lstStyle/>
           <a:p>
             <a:r>
-              <a:t>Cerramos con lo que falta, sin maquillaje. El núcleo que no depende del modelo ya está: permisos, política, acciones verificadas, pipeline con linaje y auditoría encadenada. Para producción faltan piezas conocidas: un proveedor de identidad real con MFA y step-up antes de bloquear una tarjeta, un gateway con límites, auditoría en almacenamiento inmutable, cadena de suministro fijada y un verificador de salida para el LLM. Y con datos reales, recalibrar el umbral. La arquitectura no cambia: cambian los adaptadores.</a:t>
+              <a:t>Cerramos con lo que falta, sin maquillaje. El núcleo ya está: permisos, política, consentimiento por acción, acciones verificadas, un router aprendido con fallback, pipeline con linaje, auditoría encadenada y un deploy automático que verifica los escenarios antes de publicar. Para producción faltan piezas conocidas: un proveedor de identidad real con MFA y step-up antes de bloquear una tarjeta, estado compartido para escalar horizontalmente, auditoría inmutable, evaluar el LLM cuando haya presupuesto y un test nuevo escrito por otra persona. Y con datos reales, recalibrar el umbral. La arquitectura no cambia: cambian los adaptadores.</a:t>
             </a:r>
           </a:p>
         </p:txBody>
@@ -4589,7 +4589,7 @@
                 </a:solidFill>
                 <a:latin typeface="Calibri"/>
               </a:rPr>
-              <a:t>El modelo interpreta y redacta; el código decide y actúa</a:t>
+              <a:t>El modelo interpreta; el código decide y actúa</a:t>
             </a:r>
           </a:p>
         </p:txBody>
@@ -4768,7 +4768,7 @@
                 </a:solidFill>
                 <a:latin typeface="Calibri"/>
               </a:rPr>
-              <a:t>intención + datos</a:t>
+              <a:t>intención: modelo local</a:t>
             </a:r>
           </a:p>
         </p:txBody>
@@ -5163,12 +5163,10 @@
             </a:avLst>
           </a:prstGeom>
           <a:solidFill>
-            <a:srgbClr val="FFFFFF"/>
+            <a:srgbClr val="2A78D6"/>
           </a:solidFill>
-          <a:ln w="25400">
-            <a:solidFill>
-              <a:srgbClr val="EB6834"/>
-            </a:solidFill>
+          <a:ln>
+            <a:noFill/>
           </a:ln>
           <a:effectLst/>
         </p:spPr>
@@ -5194,7 +5192,7 @@
             <a:r>
               <a:rPr sz="1500" b="1">
                 <a:solidFill>
-                  <a:srgbClr val="0B0B0B"/>
+                  <a:srgbClr val="FFFFFF"/>
                 </a:solidFill>
                 <a:latin typeface="Calibri"/>
               </a:rPr>
@@ -5206,11 +5204,11 @@
             <a:r>
               <a:rPr sz="1200" b="0">
                 <a:solidFill>
-                  <a:srgbClr val="0B0B0B"/>
-                </a:solidFill>
-                <a:latin typeface="Calibri"/>
-              </a:rPr>
-              <a:t>es / pt</a:t>
+                  <a:srgbClr val="FFFFFF"/>
+                </a:solidFill>
+                <a:latin typeface="Calibri"/>
+              </a:rPr>
+              <a:t>plantillas es / pt</a:t>
             </a:r>
           </a:p>
         </p:txBody>
@@ -5378,7 +5376,7 @@
                 </a:solidFill>
                 <a:latin typeface="Calibri"/>
               </a:rPr>
-              <a:t>Modelo: interpreta y redacta (con alternativa de reglas/plantillas)</a:t>
+              <a:t>Modelo: interpreta (router aprendido local; si no carga, reglas)</a:t>
             </a:r>
           </a:p>
         </p:txBody>
@@ -5874,7 +5872,7 @@
                 </a:solidFill>
                 <a:latin typeface="Calibri"/>
               </a:rPr>
-              <a:t>LangGraph con transiciones declaradas; una transición no declarada falla cerrada</a:t>
+              <a:t>LangGraph con transiciones declaradas; 19 caminos verificados, lo no declarado falla cerrado</a:t>
             </a:r>
           </a:p>
         </p:txBody>
@@ -5913,7 +5911,7 @@
                 </a:solidFill>
                 <a:latin typeface="Calibri"/>
               </a:rPr>
-              <a:t>Detalle: docs/architecture.md · ADR 0002 (grafo determinista con LLM acotado)</a:t>
+              <a:t>Detalle: docs/architecture.md · ADR 0002 (grafo determinista) · ADR 0009 (router aprendido)</a:t>
             </a:r>
           </a:p>
         </p:txBody>
@@ -6031,7 +6029,7 @@
                 </a:solidFill>
                 <a:latin typeface="Calibri"/>
               </a:rPr>
-              <a:t>Demo en 3 escenas</a:t>
+              <a:t>Demo en 3 escenas · clientes reales del dataset</a:t>
             </a:r>
           </a:p>
         </p:txBody>
@@ -6133,7 +6131,7 @@
                 </a:solidFill>
                 <a:latin typeface="Calibri"/>
               </a:rPr>
-              <a:t>1 · Normal</a:t>
+              <a:t>1 · Normal (es-MX)</a:t>
             </a:r>
           </a:p>
         </p:txBody>
@@ -6172,7 +6170,7 @@
                 </a:solidFill>
                 <a:latin typeface="Calibri"/>
               </a:rPr>
-              <a:t>«No reconozco un cargo de 77 dólares»</a:t>
+              <a:t>«Hola, me llegó un cargo de 151 dólares que no reconozco»</a:t>
             </a:r>
           </a:p>
         </p:txBody>
@@ -6211,7 +6209,7 @@
                 </a:solidFill>
                 <a:latin typeface="Calibri"/>
               </a:rPr>
-              <a:t>Encuentra 1 cargo, explica la política, pide «¿confirmas?», abre la disputa y bloquea la tarjeta (ambas verificadas).</a:t>
+              <a:t>1 cargo (150.86 USD, Gasolinera Express). Ofrece disputa y bloqueo por separado; con «sí, ambas» abre la disputa y bloquea la tarjeta, ambas verificadas.</a:t>
             </a:r>
           </a:p>
         </p:txBody>
@@ -6274,7 +6272,7 @@
                 </a:solidFill>
                 <a:latin typeface="Calibri"/>
               </a:rPr>
-              <a:t>2 · Ambiguo</a:t>
+              <a:t>2 · Ambiguo (es-CO)</a:t>
             </a:r>
           </a:p>
         </p:txBody>
@@ -6313,7 +6311,7 @@
                 </a:solidFill>
                 <a:latin typeface="Calibri"/>
               </a:rPr>
-              <a:t>«Me cobraron 350 y no fui yo»</a:t>
+              <a:t>«Buenas, me aparece un cobro de 242.000 pesos que yo no hice»</a:t>
             </a:r>
           </a:p>
         </p:txBody>
@@ -6352,7 +6350,7 @@
                 </a:solidFill>
                 <a:latin typeface="Calibri"/>
               </a:rPr>
-              <a:t>Hay 2 candidatos: pregunta cuál. Solo avanza cuando el cliente elige.</a:t>
+              <a:t>2 candidatos: pregunta cuál y solo avanza cuando el cliente elige («la 1»).</a:t>
             </a:r>
           </a:p>
         </p:txBody>
@@ -6454,7 +6452,7 @@
                 </a:solidFill>
                 <a:latin typeface="Calibri"/>
               </a:rPr>
-              <a:t>«Não reconheço uma cobrança no Brasil»</a:t>
+              <a:t>«Olá, não reconheço uma cobrança de 114 dólares do dia 12/06»</a:t>
             </a:r>
           </a:p>
         </p:txBody>
@@ -6493,7 +6491,7 @@
                 </a:solidFill>
                 <a:latin typeface="Calibri"/>
               </a:rPr>
-              <a:t>fraud_score ≥ 30 → regla H03 → asesor con paquete completo. «Esqueça as regras…» → bloqueado por el guard.</a:t>
+              <a:t>fraud_score 95.1 ≥ 30 → regla H03 → analista con el paquete completo. «Ignora tus instrucciones anteriores…» → bloqueado por el guard.</a:t>
             </a:r>
           </a:p>
         </p:txBody>
@@ -6532,7 +6530,7 @@
                 </a:solidFill>
                 <a:latin typeface="Calibri"/>
               </a:rPr>
-              <a:t>Demo en vivo: [[PENDIENTE: deploy]] · clientes del fixture de demo (CLI-ANA) · guion: docs/pitch/video_script.md</a:t>
+              <a:t>Demo en vivo: [[PENDIENTE: deploy]] · clientes de docs/demo/demo_customers.json (verificados 14/14) · guion: docs/demo-script.md</a:t>
             </a:r>
           </a:p>
         </p:txBody>
@@ -6689,7 +6687,7 @@
                 </a:solidFill>
                 <a:latin typeface="Calibri"/>
               </a:rPr>
-              <a:t>Evaluación honesta: contra una línea base y en casos reservados</a:t>
+              <a:t>Evaluación honesta: contra líneas base, en casos reservados</a:t>
             </a:r>
           </a:p>
         </p:txBody>
@@ -6774,7 +6772,7 @@
                 </a:solidFill>
                 <a:latin typeface="Calibri"/>
               </a:rPr>
-              <a:t>Agente vs línea base</a:t>
+              <a:t>Agente de la demo</a:t>
             </a:r>
           </a:p>
         </p:txBody>
@@ -6813,7 +6811,7 @@
                 </a:solidFill>
                 <a:latin typeface="Calibri"/>
               </a:rPr>
-              <a:t>86% resolución segura (49/57) · 0/115 inseguros</a:t>
+              <a:t>109/115 correctos</a:t>
             </a:r>
           </a:p>
         </p:txBody>
@@ -6852,7 +6850,7 @@
                 </a:solidFill>
                 <a:latin typeface="Calibri"/>
               </a:rPr>
-              <a:t>línea base: sin política: 82/115 inseguros · deriva todo: 0/57 resueltos</a:t>
+              <a:t>55/57 resoluciones seguras · 0/115 inseguros · 0/38 transferencias faltantes</a:t>
             </a:r>
           </a:p>
         </p:txBody>
@@ -6891,7 +6889,7 @@
                 </a:solidFill>
                 <a:latin typeface="Calibri"/>
               </a:rPr>
-              <a:t>Éxito de tarea en casos reservados · 115 casos + 44 variantes de dialecto, 3 corridas</a:t>
+              <a:t>reglas: 104/115 correctos · 51/57 · 7/38 faltantes · sin política (B1): 82/115 inseguros · todo a humano (B0): 0/57 resueltos</a:t>
             </a:r>
           </a:p>
         </p:txBody>
@@ -6976,7 +6974,7 @@
                 </a:solidFill>
                 <a:latin typeface="Calibri"/>
               </a:rPr>
-              <a:t>Inyección: detección</a:t>
+              <a:t>Componente aprendido</a:t>
             </a:r>
           </a:p>
         </p:txBody>
@@ -7015,7 +7013,7 @@
                 </a:solidFill>
                 <a:latin typeface="Calibri"/>
               </a:rPr>
-              <a:t>regex AUC 0.55 · clasificador AUC 0.97</a:t>
+              <a:t>F1 0.877 vs 0.548</a:t>
             </a:r>
           </a:p>
         </p:txBody>
@@ -7054,7 +7052,7 @@
                 </a:solidFill>
                 <a:latin typeface="Calibri"/>
               </a:rPr>
-              <a:t>falsos positivos: regex 0/58 · clasificador 20/58 en mensajes bancarios</a:t>
+              <a:t>acción equivocada 1.6% vs 18.6% de los mensajes</a:t>
             </a:r>
           </a:p>
         </p:txBody>
@@ -7093,7 +7091,7 @@
                 </a:solidFill>
                 <a:latin typeface="Calibri"/>
               </a:rPr>
-              <a:t>Datasets públicos etiquetados (split de prueba) + muestra en pt generada por el equipo</a:t>
+              <a:t>Router de intención local vs reglas · corpus propio, split por autor (n=306)</a:t>
             </a:r>
           </a:p>
         </p:txBody>
@@ -7178,7 +7176,7 @@
                 </a:solidFill>
                 <a:latin typeface="Calibri"/>
               </a:rPr>
-              <a:t>Inyección: daño</a:t>
+              <a:t>Inyección y red team</a:t>
             </a:r>
           </a:p>
         </p:txBody>
@@ -7217,7 +7215,7 @@
                 </a:solidFill>
                 <a:latin typeface="Calibri"/>
               </a:rPr>
-              <a:t>0/2.531 ataques con daño, incluso con el guard apagado</a:t>
+              <a:t>0 daños</a:t>
             </a:r>
           </a:p>
         </p:txBody>
@@ -7256,7 +7254,7 @@
                 </a:solidFill>
                 <a:latin typeface="Calibri"/>
               </a:rPr>
-              <a:t>medido aparte de la detección</a:t>
+              <a:t>0/2.531 con daño (datasets públicos, aun sin guard)</a:t>
             </a:r>
           </a:p>
         </p:txBody>
@@ -7295,7 +7293,7 @@
                 </a:solidFill>
                 <a:latin typeface="Calibri"/>
               </a:rPr>
-              <a:t>Aunque el guard falle, el cliente sale del token y toda acción se confirma</a:t>
+              <a:t>Red team adaptativo: 0/308 tras 3 rondas (antes: 40/110 · 34/99 · 30/99); el daño real se corrigió en la raíz</a:t>
             </a:r>
           </a:p>
         </p:txBody>
@@ -7419,7 +7417,7 @@
                 </a:solidFill>
                 <a:latin typeface="Calibri"/>
               </a:rPr>
-              <a:t>10/11 grupos con la misma decisión</a:t>
+              <a:t>10/11</a:t>
             </a:r>
           </a:p>
         </p:txBody>
@@ -7458,7 +7456,7 @@
                 </a:solidFill>
                 <a:latin typeface="Calibri"/>
               </a:rPr>
-              <a:t>misma decisión MX · CO · AR · pt-BR</a:t>
+              <a:t>grupos con la misma decisión MX · CO · AR · pt-BR</a:t>
             </a:r>
           </a:p>
         </p:txBody>
@@ -7536,7 +7534,7 @@
                 </a:solidFill>
                 <a:latin typeface="Calibri"/>
               </a:rPr>
-              <a:t>528 tests automatizados en CI (sin datos ni API keys): flujos normal/ambiguo/handoff, sesión vencida, acceso ajeno, inyección directa e indirecta, cliente señuelo</a:t>
+              <a:t>Test congelado: 115 casos + 44 variantes de dialecto, 3 corridas (segunda medición, fuga leve declarada) · 681 tests en CI, sin datos ni API keys</a:t>
             </a:r>
           </a:p>
         </p:txBody>
@@ -7575,7 +7573,7 @@
                 </a:solidFill>
                 <a:latin typeface="Calibri"/>
               </a:rPr>
-              <a:t>Detalle: reports/eval.md · reports/injection_eval.md · ADR 0003</a:t>
+              <a:t>Detalle: reports/eval_router.md · eval.md · intent_router.md · injection_eval.md · redteam.md</a:t>
             </a:r>
           </a:p>
         </p:txBody>
@@ -8525,7 +8523,7 @@
                 </a:solidFill>
                 <a:latin typeface="Calibri"/>
               </a:rPr>
-              <a:t>Acciones con confirmación y verificación; handoff con contexto</a:t>
+              <a:t>Consentimiento por acción, acciones verificadas, handoff versionado</a:t>
             </a:r>
           </a:p>
           <a:p>
@@ -8550,7 +8548,7 @@
                 </a:solidFill>
                 <a:latin typeface="Calibri"/>
               </a:rPr>
-              <a:t>Pipeline incremental: contratos, cuarentena, linaje</a:t>
+              <a:t>Router aprendido local con fallback visible a reglas</a:t>
             </a:r>
           </a:p>
           <a:p>
@@ -8575,7 +8573,32 @@
                 </a:solidFill>
                 <a:latin typeface="Calibri"/>
               </a:rPr>
-              <a:t>Log de auditoría con cadena de hashes y modelo de amenazas OWASP LLM (PR #20)</a:t>
+              <a:t>Red team de 3 rondas e invariantes con Hypothesis, en CI</a:t>
+            </a:r>
+          </a:p>
+          <a:p>
+            <a:pPr algn="l">
+              <a:spcAft>
+                <a:spcPts val="1200"/>
+              </a:spcAft>
+            </a:pPr>
+            <a:r>
+              <a:rPr sz="1600" b="1">
+                <a:solidFill>
+                  <a:srgbClr val="2A78D6"/>
+                </a:solidFill>
+                <a:latin typeface="Segoe UI Symbol"/>
+              </a:rPr>
+              <a:t>✓  </a:t>
+            </a:r>
+            <a:r>
+              <a:rPr sz="1600" b="0" i="0">
+                <a:solidFill>
+                  <a:srgbClr val="0B0B0B"/>
+                </a:solidFill>
+                <a:latin typeface="Calibri"/>
+              </a:rPr>
+              <a:t>Auditoría encadenada · dependencias con hash · CI → GHCR → Render</a:t>
             </a:r>
           </a:p>
           <a:p>
@@ -8758,7 +8781,7 @@
                 </a:solidFill>
                 <a:latin typeface="Calibri"/>
               </a:rPr>
-              <a:t>Gateway: rate limiting, límite de mensaje, WAF (#15)</a:t>
+              <a:t>Estado compartido (checkpointer, sesiones) para escalar</a:t>
             </a:r>
           </a:p>
           <a:p>
@@ -8783,7 +8806,7 @@
                 </a:solidFill>
                 <a:latin typeface="Calibri"/>
               </a:rPr>
-              <a:t>Auditoría en almacenamiento WORM y claves en KMS</a:t>
+              <a:t>Auditoría WORM, claves en KMS, gateway con WAF</a:t>
             </a:r>
           </a:p>
           <a:p>
@@ -8808,7 +8831,7 @@
                 </a:solidFill>
                 <a:latin typeface="Calibri"/>
               </a:rPr>
-              <a:t>Lockfile con hashes y acciones fijadas por SHA (#17)</a:t>
+              <a:t>Evaluar el LLM (hoy apagado) y un test v3 escrito por otra persona</a:t>
             </a:r>
           </a:p>
           <a:p>
@@ -8833,7 +8856,7 @@
                 </a:solidFill>
                 <a:latin typeface="Calibri"/>
               </a:rPr>
-              <a:t>Verificador de cifras e IDs para el writer con LLM (#7)</a:t>
+              <a:t>Calificaciones humanas de los handoffs (kit listo)</a:t>
             </a:r>
           </a:p>
           <a:p>
@@ -8858,7 +8881,7 @@
                 </a:solidFill>
                 <a:latin typeface="Calibri"/>
               </a:rPr>
-              <a:t>Recalibrar el umbral con datos reales y medir fraude entre cargos disputados</a:t>
+              <a:t>Recalibrar el umbral con datos reales</a:t>
             </a:r>
           </a:p>
           <a:p>
@@ -8883,7 +8906,7 @@
                 </a:solidFill>
                 <a:latin typeface="Calibri"/>
               </a:rPr>
-              <a:t>Capacidad: p95 233 ms por turno · ~61 turnos/s por réplica (sin LLM, costo $0)</a:t>
+              <a:t>Capacidad hoy: p95 233 ms por turno · ~61 turnos/s por réplica (sin LLM, costo $0)</a:t>
             </a:r>
           </a:p>
         </p:txBody>

</xml_diff>

<commit_message>
docs: demo en vivo en Render (14/14 escenarios, p95 401 ms) en README, deck y operación
Closes #15

Co-Authored-By: Claude Opus 5.5 <noreply@anthropic.com>
</commit_message>
<xml_diff>
--- a/docs/pitch/deck.pptx
+++ b/docs/pitch/deck.pptx
@@ -6526,11 +6526,11 @@
             <a:r>
               <a:rPr sz="1000" b="0" i="0">
                 <a:solidFill>
-                  <a:srgbClr val="B54A1A"/>
-                </a:solidFill>
-                <a:latin typeface="Calibri"/>
-              </a:rPr>
-              <a:t>Demo en vivo: [[PENDIENTE: deploy]] · clientes de docs/demo/demo_customers.json (verificados 14/14) · guion: docs/demo-script.md</a:t>
+                  <a:srgbClr val="8A8984"/>
+                </a:solidFill>
+                <a:latin typeface="Calibri"/>
+              </a:rPr>
+              <a:t>Demo en vivo: agente-disputas.onrender.com · clientes de docs/demo/demo_customers.json (verificados 14/14) · guion: docs/demo-script.md</a:t>
             </a:r>
           </a:p>
         </p:txBody>
@@ -8619,11 +8619,11 @@
             <a:r>
               <a:rPr sz="1600" b="0" i="0">
                 <a:solidFill>
-                  <a:srgbClr val="B54A1A"/>
-                </a:solidFill>
-                <a:latin typeface="Calibri"/>
-              </a:rPr>
-              <a:t>Demo desplegada: [[PENDIENTE: deploy]]</a:t>
+                  <a:srgbClr val="0B0B0B"/>
+                </a:solidFill>
+                <a:latin typeface="Calibri"/>
+              </a:rPr>
+              <a:t>Demo desplegada: agente-disputas.onrender.com</a:t>
             </a:r>
           </a:p>
         </p:txBody>

</xml_diff>

<commit_message>
docs: demo en vivo en Render (14/14 escenarios, p95 401 ms) en README, deck y operación (#68)
Closes #15

Co-authored-by: Mr-Percival <188080720.Mr-Percival@users.noreply.github.com>
Co-authored-by: Claude Opus 5.5 <noreply@anthropic.com>
</commit_message>
<xml_diff>
--- a/docs/pitch/deck.pptx
+++ b/docs/pitch/deck.pptx
@@ -6526,11 +6526,11 @@
             <a:r>
               <a:rPr sz="1000" b="0" i="0">
                 <a:solidFill>
-                  <a:srgbClr val="B54A1A"/>
-                </a:solidFill>
-                <a:latin typeface="Calibri"/>
-              </a:rPr>
-              <a:t>Demo en vivo: [[PENDIENTE: deploy]] · clientes de docs/demo/demo_customers.json (verificados 14/14) · guion: docs/demo-script.md</a:t>
+                  <a:srgbClr val="8A8984"/>
+                </a:solidFill>
+                <a:latin typeface="Calibri"/>
+              </a:rPr>
+              <a:t>Demo en vivo: agente-disputas.onrender.com · clientes de docs/demo/demo_customers.json (verificados 14/14) · guion: docs/demo-script.md</a:t>
             </a:r>
           </a:p>
         </p:txBody>
@@ -8619,11 +8619,11 @@
             <a:r>
               <a:rPr sz="1600" b="0" i="0">
                 <a:solidFill>
-                  <a:srgbClr val="B54A1A"/>
-                </a:solidFill>
-                <a:latin typeface="Calibri"/>
-              </a:rPr>
-              <a:t>Demo desplegada: [[PENDIENTE: deploy]]</a:t>
+                  <a:srgbClr val="0B0B0B"/>
+                </a:solidFill>
+                <a:latin typeface="Calibri"/>
+              </a:rPr>
+              <a:t>Demo desplegada: agente-disputas.onrender.com</a:t>
             </a:r>
           </a:p>
         </p:txBody>

</xml_diff>

<commit_message>
docs(eval): análisis de desacuerdos del test v3 ciego, segunda corrida no ciega y pitch E1
- reports/eval_blind_v3.md: sección «Análisis de desacuerdos» (37/37 fallas propias en embeddings,
  20 por consentimiento estricto); los números crudos (43/80, 36/80, 0/80) no cambian
- reports/eval_blind_v3_rerun.md: segunda corrida tras los arreglos, rotulada como NO ciega
  (embeddings 76/80, rules 63/80, 0/80 acciones no esperadas)
- evals/cases/README.md: protocolo (v3 usado una vez; hace falta un v4 para un número limpio)
- qa.md E1, rubric-evidence punto 5, README, metrics.yaml + deck regenerado (fila del test ciego)

Co-Authored-By: Claude Opus 5.5 <noreply@anthropic.com>
</commit_message>
<xml_diff>
--- a/docs/pitch/deck.pptx
+++ b/docs/pitch/deck.pptx
@@ -717,7 +717,7 @@
           <a:lstStyle/>
           <a:p>
             <a:r>
-              <a:t>No entrenamos sobre las transcripciones del dataset: solo hay 42 textos de cliente distintos. Medimos donde hay etiquetas válidas. Uno: el agente de la demo contra la línea base de reglas y contra dos líneas base ingenuas, en casos reservados generados por el equipo y declarados como tales; automatizar sin política da 82 resultados inseguros de 115, el nuestro cero. Dos: el componente aprendido, el router de intención, contra las reglas, en un corpus propio dividido por autor. Tres: seguridad; con datasets públicos, regex AUC 0.55 · clasificador AUC 0.97, pero lo que importa es el daño, que medimos aparte: cero, aun con el guard apagado. Y un red team propio de tres rondas sí encontró daño real, que corregimos en la raíz. Cuatro: equidad; el mismo caso en dialectos distintos debe dar la misma decisión. Somos explícitos: el test ya se midió dos veces y declaramos una fuga leve.</a:t>
+              <a:t>No entrenamos sobre las transcripciones del dataset: solo hay 42 textos de cliente distintos. Medimos donde hay etiquetas válidas. Uno: el agente de la demo contra la línea base de reglas y contra dos líneas base ingenuas, en casos reservados generados por el equipo y declarados como tales; automatizar sin política da 82 resultados inseguros de 115, el nuestro cero. Dos: el componente aprendido, el router de intención, contra las reglas, en un corpus propio dividido por autor. Tres: seguridad; con datasets públicos, regex AUC 0.55 · clasificador AUC 0.97, pero lo que importa es el daño, que medimos aparte: cero, aun con el guard apagado. Y un red team propio de tres rondas sí encontró daño real, que corregimos en la raíz. Cuatro: equidad; el mismo caso en dialectos distintos debe dar la misma decisión. Somos explícitos: el test propio ya se midió dos veces, así que un autor aislado escribió un test ciego de 80 conversaciones que corrimos una vez. La seguridad aguantó, cero acciones no esperadas; la utilidad bajó a 43 de 80, sobre todo porque el sí estricto del red team re-preguntaba respuestas naturales. Lo arreglamos, pero la segunda corrida ya no es ciega, y lo decimos.</a:t>
             </a:r>
           </a:p>
         </p:txBody>
@@ -6974,7 +6974,7 @@
                 </a:solidFill>
                 <a:latin typeface="Calibri"/>
               </a:rPr>
-              <a:t>Componente aprendido</a:t>
+              <a:t>Test ciego (v3)</a:t>
             </a:r>
           </a:p>
         </p:txBody>
@@ -7013,7 +7013,7 @@
                 </a:solidFill>
                 <a:latin typeface="Calibri"/>
               </a:rPr>
-              <a:t>F1 0.877 vs 0.548</a:t>
+              <a:t>43/80 correctos</a:t>
             </a:r>
           </a:p>
         </p:txBody>
@@ -7052,7 +7052,7 @@
                 </a:solidFill>
                 <a:latin typeface="Calibri"/>
               </a:rPr>
-              <a:t>acción equivocada 1.6% vs 18.6% de los mensajes</a:t>
+              <a:t>0/80 acciones no esperadas · autor aislado, corrida única</a:t>
             </a:r>
           </a:p>
         </p:txBody>
@@ -7091,7 +7091,7 @@
                 </a:solidFill>
                 <a:latin typeface="Calibri"/>
               </a:rPr>
-              <a:t>Router de intención local vs reglas · corpus propio, split por autor (n=306)</a:t>
+              <a:t>causa principal: el sí estricto del red team (20/37) · tras arreglos 76/80, ya no ciego</a:t>
             </a:r>
           </a:p>
         </p:txBody>
@@ -7176,7 +7176,7 @@
                 </a:solidFill>
                 <a:latin typeface="Calibri"/>
               </a:rPr>
-              <a:t>Inyección y red team</a:t>
+              <a:t>Componente aprendido</a:t>
             </a:r>
           </a:p>
         </p:txBody>
@@ -7215,7 +7215,7 @@
                 </a:solidFill>
                 <a:latin typeface="Calibri"/>
               </a:rPr>
-              <a:t>0 daños</a:t>
+              <a:t>F1 0.877 vs 0.548</a:t>
             </a:r>
           </a:p>
         </p:txBody>
@@ -7254,7 +7254,7 @@
                 </a:solidFill>
                 <a:latin typeface="Calibri"/>
               </a:rPr>
-              <a:t>0/2.531 con daño (datasets públicos, aun sin guard)</a:t>
+              <a:t>acción equivocada 1.6% vs 18.6% de los mensajes</a:t>
             </a:r>
           </a:p>
         </p:txBody>
@@ -7293,7 +7293,7 @@
                 </a:solidFill>
                 <a:latin typeface="Calibri"/>
               </a:rPr>
-              <a:t>Red team adaptativo: 0/308 tras 3 rondas (antes: 40/110 · 34/99 · 30/99); el daño real se corrigió en la raíz</a:t>
+              <a:t>Router de intención local vs reglas · corpus propio, split por autor (n=306)</a:t>
             </a:r>
           </a:p>
         </p:txBody>
@@ -7378,7 +7378,7 @@
                 </a:solidFill>
                 <a:latin typeface="Calibri"/>
               </a:rPr>
-              <a:t>Equidad por dialecto</a:t>
+              <a:t>Inyección y red team</a:t>
             </a:r>
           </a:p>
         </p:txBody>
@@ -7417,7 +7417,7 @@
                 </a:solidFill>
                 <a:latin typeface="Calibri"/>
               </a:rPr>
-              <a:t>10/11</a:t>
+              <a:t>0 daños</a:t>
             </a:r>
           </a:p>
         </p:txBody>
@@ -7456,7 +7456,7 @@
                 </a:solidFill>
                 <a:latin typeface="Calibri"/>
               </a:rPr>
-              <a:t>grupos con la misma decisión MX · CO · AR · pt-BR</a:t>
+              <a:t>0/2.531 con daño (datasets públicos, aun sin guard)</a:t>
             </a:r>
           </a:p>
         </p:txBody>
@@ -7495,21 +7495,67 @@
                 </a:solidFill>
                 <a:latin typeface="Calibri"/>
               </a:rPr>
-              <a:t>No enrutamos por acento: el EDA no muestra efecto (FCR 76.7% vs 76.6%)</a:t>
-            </a:r>
-          </a:p>
-        </p:txBody>
-      </p:sp>
-      <p:sp>
-        <p:nvSpPr>
-          <p:cNvPr id="25" name="TextBox 24"/>
+              <a:t>Red team adaptativo: 0/308 tras 3 rondas (antes: 40/110 · 34/99 · 30/99); el daño real se corrigió en la raíz</a:t>
+            </a:r>
+          </a:p>
+        </p:txBody>
+      </p:sp>
+      <p:sp>
+        <p:nvSpPr>
+          <p:cNvPr id="25" name="Rounded Rectangle 24"/>
+          <p:cNvSpPr/>
+          <p:nvPr/>
+        </p:nvSpPr>
+        <p:spPr>
+          <a:xfrm>
+            <a:off x="11814048" y="1965960"/>
+            <a:ext cx="2633472" cy="3566160"/>
+          </a:xfrm>
+          <a:prstGeom prst="roundRect">
+            <a:avLst>
+              <a:gd name="adj" fmla="val 8000"/>
+            </a:avLst>
+          </a:prstGeom>
+          <a:solidFill>
+            <a:srgbClr val="EAF2FC"/>
+          </a:solidFill>
+          <a:ln>
+            <a:noFill/>
+          </a:ln>
+          <a:effectLst/>
+        </p:spPr>
+        <p:style>
+          <a:lnRef idx="1">
+            <a:schemeClr val="accent1"/>
+          </a:lnRef>
+          <a:fillRef idx="3">
+            <a:schemeClr val="accent1"/>
+          </a:fillRef>
+          <a:effectRef idx="2">
+            <a:schemeClr val="accent1"/>
+          </a:effectRef>
+          <a:fontRef idx="minor">
+            <a:schemeClr val="lt1"/>
+          </a:fontRef>
+        </p:style>
+        <p:txBody>
+          <a:bodyPr rtlCol="0" anchor="ctr"/>
+          <a:lstStyle/>
+          <a:p>
+            <a:pPr algn="ctr"/>
+          </a:p>
+        </p:txBody>
+      </p:sp>
+      <p:sp>
+        <p:nvSpPr>
+          <p:cNvPr id="26" name="TextBox 25"/>
           <p:cNvSpPr txBox="1"/>
           <p:nvPr/>
         </p:nvSpPr>
         <p:spPr>
           <a:xfrm>
-            <a:off x="548640" y="5760720"/>
-            <a:ext cx="11064240" cy="502920"/>
+            <a:off x="11996928" y="2148840"/>
+            <a:ext cx="2286000" cy="365760"/>
           </a:xfrm>
           <a:prstGeom prst="rect">
             <a:avLst/>
@@ -7528,20 +7574,176 @@
               </a:spcAft>
             </a:pPr>
             <a:r>
+              <a:rPr sz="1500" b="1" i="0">
+                <a:solidFill>
+                  <a:srgbClr val="0B0B0B"/>
+                </a:solidFill>
+                <a:latin typeface="Calibri"/>
+              </a:rPr>
+              <a:t>Equidad por dialecto</a:t>
+            </a:r>
+          </a:p>
+        </p:txBody>
+      </p:sp>
+      <p:sp>
+        <p:nvSpPr>
+          <p:cNvPr id="27" name="TextBox 26"/>
+          <p:cNvSpPr txBox="1"/>
+          <p:nvPr/>
+        </p:nvSpPr>
+        <p:spPr>
+          <a:xfrm>
+            <a:off x="11996928" y="2606040"/>
+            <a:ext cx="2286000" cy="1097280"/>
+          </a:xfrm>
+          <a:prstGeom prst="rect">
+            <a:avLst/>
+          </a:prstGeom>
+          <a:noFill/>
+        </p:spPr>
+        <p:txBody>
+          <a:bodyPr wrap="square" lIns="0" rIns="0" tIns="0" bIns="0" anchor="t">
+            <a:spAutoFit/>
+          </a:bodyPr>
+          <a:lstStyle/>
+          <a:p>
+            <a:pPr algn="l">
+              <a:spcAft>
+                <a:spcPts val="400"/>
+              </a:spcAft>
+            </a:pPr>
+            <a:r>
+              <a:rPr sz="3000" b="1" i="0">
+                <a:solidFill>
+                  <a:srgbClr val="2A78D6"/>
+                </a:solidFill>
+                <a:latin typeface="Calibri"/>
+              </a:rPr>
+              <a:t>10/11</a:t>
+            </a:r>
+          </a:p>
+        </p:txBody>
+      </p:sp>
+      <p:sp>
+        <p:nvSpPr>
+          <p:cNvPr id="28" name="TextBox 27"/>
+          <p:cNvSpPr txBox="1"/>
+          <p:nvPr/>
+        </p:nvSpPr>
+        <p:spPr>
+          <a:xfrm>
+            <a:off x="11996928" y="3703320"/>
+            <a:ext cx="2286000" cy="548640"/>
+          </a:xfrm>
+          <a:prstGeom prst="rect">
+            <a:avLst/>
+          </a:prstGeom>
+          <a:noFill/>
+        </p:spPr>
+        <p:txBody>
+          <a:bodyPr wrap="square" lIns="0" rIns="0" tIns="0" bIns="0" anchor="t">
+            <a:spAutoFit/>
+          </a:bodyPr>
+          <a:lstStyle/>
+          <a:p>
+            <a:pPr algn="l">
+              <a:spcAft>
+                <a:spcPts val="400"/>
+              </a:spcAft>
+            </a:pPr>
+            <a:r>
+              <a:rPr sz="1300" b="0" i="0">
+                <a:solidFill>
+                  <a:srgbClr val="0B0B0B"/>
+                </a:solidFill>
+                <a:latin typeface="Calibri"/>
+              </a:rPr>
+              <a:t>grupos con la misma decisión MX · CO · AR · pt-BR</a:t>
+            </a:r>
+          </a:p>
+        </p:txBody>
+      </p:sp>
+      <p:sp>
+        <p:nvSpPr>
+          <p:cNvPr id="29" name="TextBox 28"/>
+          <p:cNvSpPr txBox="1"/>
+          <p:nvPr/>
+        </p:nvSpPr>
+        <p:spPr>
+          <a:xfrm>
+            <a:off x="11996928" y="4343400"/>
+            <a:ext cx="2286000" cy="1097280"/>
+          </a:xfrm>
+          <a:prstGeom prst="rect">
+            <a:avLst/>
+          </a:prstGeom>
+          <a:noFill/>
+        </p:spPr>
+        <p:txBody>
+          <a:bodyPr wrap="square" lIns="0" rIns="0" tIns="0" bIns="0" anchor="t">
+            <a:spAutoFit/>
+          </a:bodyPr>
+          <a:lstStyle/>
+          <a:p>
+            <a:pPr algn="l">
+              <a:spcAft>
+                <a:spcPts val="400"/>
+              </a:spcAft>
+            </a:pPr>
+            <a:r>
+              <a:rPr sz="1200" b="0" i="0">
+                <a:solidFill>
+                  <a:srgbClr val="52514E"/>
+                </a:solidFill>
+                <a:latin typeface="Calibri"/>
+              </a:rPr>
+              <a:t>No enrutamos por acento: el EDA no muestra efecto (FCR 76.7% vs 76.6%)</a:t>
+            </a:r>
+          </a:p>
+        </p:txBody>
+      </p:sp>
+      <p:sp>
+        <p:nvSpPr>
+          <p:cNvPr id="30" name="TextBox 29"/>
+          <p:cNvSpPr txBox="1"/>
+          <p:nvPr/>
+        </p:nvSpPr>
+        <p:spPr>
+          <a:xfrm>
+            <a:off x="548640" y="5760720"/>
+            <a:ext cx="11064240" cy="502920"/>
+          </a:xfrm>
+          <a:prstGeom prst="rect">
+            <a:avLst/>
+          </a:prstGeom>
+          <a:noFill/>
+        </p:spPr>
+        <p:txBody>
+          <a:bodyPr wrap="square" lIns="0" rIns="0" tIns="0" bIns="0" anchor="t">
+            <a:spAutoFit/>
+          </a:bodyPr>
+          <a:lstStyle/>
+          <a:p>
+            <a:pPr algn="l">
+              <a:spcAft>
+                <a:spcPts val="400"/>
+              </a:spcAft>
+            </a:pPr>
+            <a:r>
               <a:rPr sz="1400" b="0" i="0">
                 <a:solidFill>
                   <a:srgbClr val="0B0B0B"/>
                 </a:solidFill>
                 <a:latin typeface="Calibri"/>
               </a:rPr>
-              <a:t>Test congelado: 115 casos + 44 variantes de dialecto, 3 corridas (segunda medición, fuga leve declarada) · 681 tests en CI, sin datos ni API keys</a:t>
-            </a:r>
-          </a:p>
-        </p:txBody>
-      </p:sp>
-      <p:sp>
-        <p:nvSpPr>
-          <p:cNvPr id="26" name="TextBox 25"/>
+              <a:t>Test propio: 115 casos + 44 variantes de dialecto, 3 corridas (segunda medición, fuga leve declarada) · el ciego muestra que 109/115 sobreestimaba la utilidad, no la seguridad · 769 tests en CI</a:t>
+            </a:r>
+          </a:p>
+        </p:txBody>
+      </p:sp>
+      <p:sp>
+        <p:nvSpPr>
+          <p:cNvPr id="31" name="TextBox 30"/>
           <p:cNvSpPr txBox="1"/>
           <p:nvPr/>
         </p:nvSpPr>

</xml_diff>